<commit_message>
feat: adiciona slide da implementacao do BFS ao slide
</commit_message>
<xml_diff>
--- a/T1/apresentacao/apresentacao.pptx
+++ b/T1/apresentacao/apresentacao.pptx
@@ -14,6 +14,7 @@
     <p:sldId id="260" r:id="rId13"/>
     <p:sldId id="261" r:id="rId14"/>
     <p:sldId id="262" r:id="rId15"/>
+    <p:sldId id="264" r:id="rId17"/>
     <p:sldId id="263" r:id="rId16"/>
     <p:sldId id="259" r:id="rId8"/>
   </p:sldIdLst>
@@ -1480,7 +1481,65 @@
           <a:lstStyle/>
           <a:p>
             <a:r>
-              <a:t>Slide 5 (~1 min). Testamos seis casos pequenos e dois de estresse. O caso das diagonais foi de proposito: se a adjacencia estivesse errada, aceitando diagonal, ele daria 1 em vez de 4. Os dois de estresse cobrem os extremos — uma regiao com um milhao de vertices e quinhentas mil regioes minimas — e os dois rodam em menos de tres decimos de segundo. A complexidade e O de H vezes W, linear no numero de posicoes, porque cada piso entra na fila uma vez so. Com isso o codigo recebeu Accepted no CSES, passando nos 19 testes do juiz, com pior tempo de 0,34 segundo contra um limite de 1 segundo. Obrigado, estamos a disposicao para perguntas.</a:t>
+              <a:t>Slide 6 (~1 min). Testamos seis casos pequenos e dois de estresse. O caso das diagonais foi de proposito: se a adjacencia estivesse errada, aceitando diagonal, ele daria 1 em vez de 4. Os dois de estresse cobrem os extremos — uma regiao com um milhao de vertices e quinhentas mil regioes minimas — e os dois rodam em menos de tres decimos de segundo. A complexidade e O de H vezes W, linear no numero de posicoes, porque cada piso entra na fila uma vez so. Com isso o codigo recebeu Accepted no CSES, passando nos 19 testes do juiz, com pior tempo de 0,34 segundo contra um limite de 1 segundo. Obrigado, estamos a disposicao para perguntas.</a:t>
+            </a:r>
+          </a:p>
+        </p:txBody>
+      </p:sp>
+    </p:spTree>
+  </p:cSld>
+  <p:clrMapOvr>
+    <a:masterClrMapping/>
+  </p:clrMapOvr>
+</p:notes>
+</file>
+
+<file path=ppt/notesSlides/notesSlide9.xml><?xml version="1.0" encoding="utf-8"?>
+<p:notes xmlns:a="http://schemas.openxmlformats.org/drawingml/2006/main" xmlns:p="http://schemas.openxmlformats.org/presentationml/2006/main" xmlns:r="http://schemas.openxmlformats.org/officeDocument/2006/relationships">
+  <p:cSld>
+    <p:spTree>
+      <p:nvGrpSpPr>
+        <p:cNvPr id="1" name=""/>
+        <p:cNvGrpSpPr/>
+        <p:nvPr/>
+      </p:nvGrpSpPr>
+      <p:grpSpPr>
+        <a:xfrm>
+          <a:off x="0" y="0"/>
+          <a:ext cx="0" cy="0"/>
+          <a:chOff x="0" y="0"/>
+          <a:chExt cx="0" cy="0"/>
+        </a:xfrm>
+      </p:grpSpPr>
+      <p:sp>
+        <p:nvSpPr>
+          <p:cNvPr id="2" name="Slide Image Placeholder 1"/>
+          <p:cNvSpPr>
+            <a:spLocks noGrp="1"/>
+          </p:cNvSpPr>
+          <p:nvPr>
+            <p:ph type="sldImg" idx="2"/>
+          </p:nvPr>
+        </p:nvSpPr>
+        <p:spPr/>
+      </p:sp>
+      <p:sp>
+        <p:nvSpPr>
+          <p:cNvPr id="3" name="Notes Placeholder 2"/>
+          <p:cNvSpPr>
+            <a:spLocks noGrp="1"/>
+          </p:cNvSpPr>
+          <p:nvPr>
+            <p:ph type="body" idx="1"/>
+          </p:nvPr>
+        </p:nvSpPr>
+        <p:spPr/>
+        <p:txBody>
+          <a:bodyPr/>
+          <a:lstStyle/>
+          <a:p>
+            <a:r>
+              <a:t>Slide 5 (~1 min). Esta e a funcao bfs, o coracao da solucao. Ela recebe um piso ainda nao visitado, marca esse piso e coloca ele na fila — a fila e a estrutura Queue do algs4, com enqueue e dequeue. Cada vertice viaja na fila como um unico inteiro, linha vezes colunas mais coluna, e linha e coluna voltam com divisao e resto. No laco, tira um da frente, olha os quatro vizinhos e, para cada vizinho valido, marca ANTES de enfileirar. Marcar na entrada e o que garante que ninguem entra duas vezes na fila; se marcassemos na saida, o mesmo piso poderia ser enfileirado por dois vizinhos diferentes. Quando a fila esvazia, a sala inteira foi visitada e o laco principal segue procurando a proxima. E tudo iterativo: nao existe pilha de recursao para estourar.</a:t>
             </a:r>
           </a:p>
         </p:txBody>
@@ -13274,6 +13333,682 @@
 </p:sld>
 </file>
 
+<file path=ppt/slides/slide9.xml><?xml version="1.0" encoding="utf-8"?>
+<p:sld xmlns:a="http://schemas.openxmlformats.org/drawingml/2006/main" xmlns:p="http://schemas.openxmlformats.org/presentationml/2006/main" xmlns:r="http://schemas.openxmlformats.org/officeDocument/2006/relationships">
+  <p:cSld>
+    <p:spTree>
+      <p:nvGrpSpPr>
+        <p:cNvPr id="1" name=""/>
+        <p:cNvGrpSpPr/>
+        <p:nvPr/>
+      </p:nvGrpSpPr>
+      <p:grpSpPr/>
+      <p:sp>
+        <p:nvSpPr>
+          <p:cNvPr id="2" name="Title 1"/>
+          <p:cNvSpPr>
+            <a:spLocks noGrp="1"/>
+          </p:cNvSpPr>
+          <p:nvPr>
+            <p:ph type="title"/>
+          </p:nvPr>
+        </p:nvSpPr>
+        <p:spPr>
+          <a:xfrm>
+            <a:off x="749808" y="274320"/>
+            <a:ext cx="7818120" cy="1051560"/>
+          </a:xfrm>
+        </p:spPr>
+        <p:txBody>
+          <a:bodyPr wrap="square"/>
+          <a:lstStyle/>
+          <a:p>
+            <a:pPr algn="l">
+              <a:lnSpc>
+                <a:spcPct val="100000"/>
+              </a:lnSpc>
+              <a:spcAft>
+                <a:spcPts val="200"/>
+              </a:spcAft>
+            </a:pPr>
+            <a:r>
+              <a:rPr sz="2850" b="1">
+                <a:solidFill>
+                  <a:srgbClr val="132190"/>
+                </a:solidFill>
+                <a:latin typeface="Arial"/>
+              </a:rPr>
+              <a:t>Implementação da BFS</a:t>
+            </a:r>
+          </a:p>
+          <a:p>
+            <a:pPr algn="l">
+              <a:lnSpc>
+                <a:spcPct val="100000"/>
+              </a:lnSpc>
+              <a:spcAft>
+                <a:spcPts val="600"/>
+              </a:spcAft>
+            </a:pPr>
+            <a:r>
+              <a:rPr sz="1500" b="0">
+                <a:solidFill>
+                  <a:srgbClr val="004AF7"/>
+                </a:solidFill>
+                <a:latin typeface="Arial"/>
+              </a:rPr>
+              <a:t>A função bfs: uma fila explícita sobre a matriz</a:t>
+            </a:r>
+          </a:p>
+        </p:txBody>
+      </p:sp>
+      <p:sp>
+        <p:nvSpPr>
+          <p:cNvPr id="3" name="TextBox 2"/>
+          <p:cNvSpPr txBox="1"/>
+          <p:nvPr/>
+        </p:nvSpPr>
+        <p:spPr>
+          <a:xfrm>
+            <a:off x="731520" y="1380000"/>
+            <a:ext cx="3200400" cy="2050000"/>
+          </a:xfrm>
+          <a:prstGeom prst="rect">
+            <a:avLst/>
+          </a:prstGeom>
+          <a:noFill/>
+        </p:spPr>
+        <p:txBody>
+          <a:bodyPr wrap="square" lIns="0" tIns="0" anchor="ctr">
+            <a:spAutoFit/>
+          </a:bodyPr>
+          <a:lstStyle/>
+          <a:p>
+            <a:pPr algn="l">
+              <a:lnSpc>
+                <a:spcPct val="105000"/>
+              </a:lnSpc>
+              <a:spcAft>
+                <a:spcPts val="900"/>
+              </a:spcAft>
+            </a:pPr>
+            <a:r>
+              <a:rPr sz="1300" b="0">
+                <a:solidFill>
+                  <a:srgbClr val="1A1A1A"/>
+                </a:solidFill>
+                <a:latin typeface="Arial"/>
+              </a:rPr>
+              <a:t>Fila explícita no lugar da recursão da DFS</a:t>
+            </a:r>
+          </a:p>
+          <a:p>
+            <a:pPr algn="l">
+              <a:lnSpc>
+                <a:spcPct val="105000"/>
+              </a:lnSpc>
+              <a:spcAft>
+                <a:spcPts val="900"/>
+              </a:spcAft>
+            </a:pPr>
+            <a:r>
+              <a:rPr sz="1300" b="0">
+                <a:solidFill>
+                  <a:srgbClr val="1A1A1A"/>
+                </a:solidFill>
+                <a:latin typeface="Arial"/>
+              </a:rPr>
+              <a:t>Marca o vizinho ao enfileirar, nunca ao remover</a:t>
+            </a:r>
+          </a:p>
+          <a:p>
+            <a:pPr algn="l">
+              <a:lnSpc>
+                <a:spcPct val="105000"/>
+              </a:lnSpc>
+              <a:spcAft>
+                <a:spcPts val="900"/>
+              </a:spcAft>
+            </a:pPr>
+            <a:r>
+              <a:rPr sz="1300" b="0">
+                <a:solidFill>
+                  <a:srgbClr val="1A1A1A"/>
+                </a:solidFill>
+                <a:latin typeface="Arial"/>
+              </a:rPr>
+              <a:t>Vértice cabe em um int: linha × colunas + coluna</a:t>
+            </a:r>
+          </a:p>
+          <a:p>
+            <a:pPr algn="l">
+              <a:lnSpc>
+                <a:spcPct val="105000"/>
+              </a:lnSpc>
+              <a:spcAft>
+                <a:spcPts val="900"/>
+              </a:spcAft>
+            </a:pPr>
+            <a:r>
+              <a:rPr sz="1300" b="0">
+                <a:solidFill>
+                  <a:srgbClr val="1A1A1A"/>
+                </a:solidFill>
+                <a:latin typeface="Arial"/>
+              </a:rPr>
+              <a:t>Fila vazia = uma sala inteira visitada</a:t>
+            </a:r>
+          </a:p>
+          <a:p>
+            <a:pPr algn="l">
+              <a:lnSpc>
+                <a:spcPct val="105000"/>
+              </a:lnSpc>
+              <a:spcAft>
+                <a:spcPts val="900"/>
+              </a:spcAft>
+            </a:pPr>
+            <a:r>
+              <a:rPr sz="1300" b="0">
+                <a:solidFill>
+                  <a:srgbClr val="1A1A1A"/>
+                </a:solidFill>
+                <a:latin typeface="Arial"/>
+              </a:rPr>
+              <a:t>Sem recursão: nenhuma pilha para estourar</a:t>
+            </a:r>
+          </a:p>
+        </p:txBody>
+      </p:sp>
+      <p:sp>
+        <p:nvSpPr>
+          <p:cNvPr id="4" name="Rounded Rectangle 3"/>
+          <p:cNvSpPr/>
+          <p:nvPr/>
+        </p:nvSpPr>
+        <p:spPr>
+          <a:xfrm>
+            <a:off x="731520" y="3550000"/>
+            <a:ext cx="3200400" cy="943356"/>
+          </a:xfrm>
+          <a:prstGeom prst="roundRect">
+            <a:avLst>
+              <a:gd name="adj" fmla="val 4000"/>
+            </a:avLst>
+          </a:prstGeom>
+          <a:solidFill>
+            <a:srgbClr val="FFFFFF"/>
+          </a:solidFill>
+          <a:ln w="12700">
+            <a:solidFill>
+              <a:srgbClr val="B9D5FB"/>
+            </a:solidFill>
+          </a:ln>
+          <a:effectLst/>
+        </p:spPr>
+        <p:style>
+          <a:lnRef idx="1">
+            <a:schemeClr val="accent1"/>
+          </a:lnRef>
+          <a:fillRef idx="3">
+            <a:schemeClr val="accent1"/>
+          </a:fillRef>
+          <a:effectRef idx="2">
+            <a:schemeClr val="accent1"/>
+          </a:effectRef>
+          <a:fontRef idx="minor">
+            <a:schemeClr val="lt1"/>
+          </a:fontRef>
+        </p:style>
+        <p:txBody>
+          <a:bodyPr rtlCol="0" anchor="t" lIns="128016" rIns="73152" tIns="91440" bIns="73152" wrap="none"/>
+          <a:lstStyle/>
+          <a:p>
+            <a:pPr algn="l">
+              <a:lnSpc>
+                <a:spcPct val="102000"/>
+              </a:lnSpc>
+              <a:spcAft>
+                <a:spcPts val="0"/>
+              </a:spcAft>
+            </a:pPr>
+            <a:r>
+              <a:rPr sz="950" b="1">
+                <a:solidFill>
+                  <a:srgbClr val="132190"/>
+                </a:solidFill>
+                <a:latin typeface="Consolas"/>
+              </a:rPr>
+              <a:t>codificação do vértice</a:t>
+            </a:r>
+          </a:p>
+          <a:p>
+            <a:pPr algn="l">
+              <a:lnSpc>
+                <a:spcPct val="102000"/>
+              </a:lnSpc>
+              <a:spcAft>
+                <a:spcPts val="0"/>
+              </a:spcAft>
+            </a:pPr>
+          </a:p>
+          <a:p>
+            <a:pPr algn="l">
+              <a:lnSpc>
+                <a:spcPct val="102000"/>
+              </a:lnSpc>
+              <a:spcAft>
+                <a:spcPts val="0"/>
+              </a:spcAft>
+            </a:pPr>
+            <a:r>
+              <a:rPr sz="950" b="0">
+                <a:solidFill>
+                  <a:srgbClr val="1A1A1A"/>
+                </a:solidFill>
+                <a:latin typeface="Consolas"/>
+              </a:rPr>
+              <a:t>id     = linha * colunas + coluna</a:t>
+            </a:r>
+          </a:p>
+          <a:p>
+            <a:pPr algn="l">
+              <a:lnSpc>
+                <a:spcPct val="102000"/>
+              </a:lnSpc>
+              <a:spcAft>
+                <a:spcPts val="0"/>
+              </a:spcAft>
+            </a:pPr>
+            <a:r>
+              <a:rPr sz="950" b="0">
+                <a:solidFill>
+                  <a:srgbClr val="1A1A1A"/>
+                </a:solidFill>
+                <a:latin typeface="Consolas"/>
+              </a:rPr>
+              <a:t>linha  = id / colunas</a:t>
+            </a:r>
+          </a:p>
+          <a:p>
+            <a:pPr algn="l">
+              <a:lnSpc>
+                <a:spcPct val="102000"/>
+              </a:lnSpc>
+              <a:spcAft>
+                <a:spcPts val="0"/>
+              </a:spcAft>
+            </a:pPr>
+            <a:r>
+              <a:rPr sz="950" b="0">
+                <a:solidFill>
+                  <a:srgbClr val="1A1A1A"/>
+                </a:solidFill>
+                <a:latin typeface="Consolas"/>
+              </a:rPr>
+              <a:t>coluna = id % colunas</a:t>
+            </a:r>
+          </a:p>
+        </p:txBody>
+      </p:sp>
+      <p:sp>
+        <p:nvSpPr>
+          <p:cNvPr id="5" name="Rounded Rectangle 4"/>
+          <p:cNvSpPr/>
+          <p:nvPr/>
+        </p:nvSpPr>
+        <p:spPr>
+          <a:xfrm>
+            <a:off x="4114800" y="1380000"/>
+            <a:ext cx="4297680" cy="2800000"/>
+          </a:xfrm>
+          <a:prstGeom prst="roundRect">
+            <a:avLst>
+              <a:gd name="adj" fmla="val 4000"/>
+            </a:avLst>
+          </a:prstGeom>
+          <a:solidFill>
+            <a:srgbClr val="FFFFFF"/>
+          </a:solidFill>
+          <a:ln w="12700">
+            <a:solidFill>
+              <a:srgbClr val="B9D5FB"/>
+            </a:solidFill>
+          </a:ln>
+          <a:effectLst/>
+        </p:spPr>
+        <p:style>
+          <a:lnRef idx="1">
+            <a:schemeClr val="accent1"/>
+          </a:lnRef>
+          <a:fillRef idx="3">
+            <a:schemeClr val="accent1"/>
+          </a:fillRef>
+          <a:effectRef idx="2">
+            <a:schemeClr val="accent1"/>
+          </a:effectRef>
+          <a:fontRef idx="minor">
+            <a:schemeClr val="lt1"/>
+          </a:fontRef>
+        </p:style>
+        <p:txBody>
+          <a:bodyPr rtlCol="0" anchor="t" lIns="128016" rIns="73152" tIns="91440" bIns="73152" wrap="none"/>
+          <a:lstStyle/>
+          <a:p>
+            <a:pPr algn="l">
+              <a:lnSpc>
+                <a:spcPct val="102000"/>
+              </a:lnSpc>
+              <a:spcAft>
+                <a:spcPts val="0"/>
+              </a:spcAft>
+            </a:pPr>
+            <a:r>
+              <a:rPr sz="900" b="0">
+                <a:solidFill>
+                  <a:srgbClr val="1A1A1A"/>
+                </a:solidFill>
+                <a:latin typeface="Consolas"/>
+              </a:rPr>
+              <a:t>private static void bfs(int linhaIni, int colunaIni) {</a:t>
+            </a:r>
+          </a:p>
+          <a:p>
+            <a:pPr algn="l">
+              <a:lnSpc>
+                <a:spcPct val="102000"/>
+              </a:lnSpc>
+              <a:spcAft>
+                <a:spcPts val="0"/>
+              </a:spcAft>
+            </a:pPr>
+            <a:r>
+              <a:rPr sz="900" b="0">
+                <a:solidFill>
+                  <a:srgbClr val="1A1A1A"/>
+                </a:solidFill>
+                <a:latin typeface="Consolas"/>
+              </a:rPr>
+              <a:t>  Queue&lt;Integer&gt; fila = new Queue&lt;Integer&gt;();</a:t>
+            </a:r>
+          </a:p>
+          <a:p>
+            <a:pPr algn="l">
+              <a:lnSpc>
+                <a:spcPct val="102000"/>
+              </a:lnSpc>
+              <a:spcAft>
+                <a:spcPts val="0"/>
+              </a:spcAft>
+            </a:pPr>
+            <a:r>
+              <a:rPr sz="900" b="1">
+                <a:solidFill>
+                  <a:srgbClr val="004AF7"/>
+                </a:solidFill>
+                <a:latin typeface="Consolas"/>
+              </a:rPr>
+              <a:t>  marcado[linhaIni][colunaIni] = true;</a:t>
+            </a:r>
+          </a:p>
+          <a:p>
+            <a:pPr algn="l">
+              <a:lnSpc>
+                <a:spcPct val="102000"/>
+              </a:lnSpc>
+              <a:spcAft>
+                <a:spcPts val="0"/>
+              </a:spcAft>
+            </a:pPr>
+            <a:r>
+              <a:rPr sz="900" b="1">
+                <a:solidFill>
+                  <a:srgbClr val="004AF7"/>
+                </a:solidFill>
+                <a:latin typeface="Consolas"/>
+              </a:rPr>
+              <a:t>  fila.enqueue(linhaIni * colunas + colunaIni);</a:t>
+            </a:r>
+          </a:p>
+          <a:p>
+            <a:pPr algn="l">
+              <a:lnSpc>
+                <a:spcPct val="102000"/>
+              </a:lnSpc>
+              <a:spcAft>
+                <a:spcPts val="0"/>
+              </a:spcAft>
+            </a:pPr>
+          </a:p>
+          <a:p>
+            <a:pPr algn="l">
+              <a:lnSpc>
+                <a:spcPct val="102000"/>
+              </a:lnSpc>
+              <a:spcAft>
+                <a:spcPts val="0"/>
+              </a:spcAft>
+            </a:pPr>
+            <a:r>
+              <a:rPr sz="900" b="0">
+                <a:solidFill>
+                  <a:srgbClr val="1A1A1A"/>
+                </a:solidFill>
+                <a:latin typeface="Consolas"/>
+              </a:rPr>
+              <a:t>  while (!fila.isEmpty()) {</a:t>
+            </a:r>
+          </a:p>
+          <a:p>
+            <a:pPr algn="l">
+              <a:lnSpc>
+                <a:spcPct val="102000"/>
+              </a:lnSpc>
+              <a:spcAft>
+                <a:spcPts val="0"/>
+              </a:spcAft>
+            </a:pPr>
+            <a:r>
+              <a:rPr sz="900" b="0">
+                <a:solidFill>
+                  <a:srgbClr val="1A1A1A"/>
+                </a:solidFill>
+                <a:latin typeface="Consolas"/>
+              </a:rPr>
+              <a:t>    int atual  = fila.dequeue();</a:t>
+            </a:r>
+          </a:p>
+          <a:p>
+            <a:pPr algn="l">
+              <a:lnSpc>
+                <a:spcPct val="102000"/>
+              </a:lnSpc>
+              <a:spcAft>
+                <a:spcPts val="0"/>
+              </a:spcAft>
+            </a:pPr>
+            <a:r>
+              <a:rPr sz="900" b="0">
+                <a:solidFill>
+                  <a:srgbClr val="1A1A1A"/>
+                </a:solidFill>
+                <a:latin typeface="Consolas"/>
+              </a:rPr>
+              <a:t>    int linha  = atual / colunas;</a:t>
+            </a:r>
+          </a:p>
+          <a:p>
+            <a:pPr algn="l">
+              <a:lnSpc>
+                <a:spcPct val="102000"/>
+              </a:lnSpc>
+              <a:spcAft>
+                <a:spcPts val="0"/>
+              </a:spcAft>
+            </a:pPr>
+            <a:r>
+              <a:rPr sz="900" b="0">
+                <a:solidFill>
+                  <a:srgbClr val="1A1A1A"/>
+                </a:solidFill>
+                <a:latin typeface="Consolas"/>
+              </a:rPr>
+              <a:t>    int coluna = atual % colunas;</a:t>
+            </a:r>
+          </a:p>
+          <a:p>
+            <a:pPr algn="l">
+              <a:lnSpc>
+                <a:spcPct val="102000"/>
+              </a:lnSpc>
+              <a:spcAft>
+                <a:spcPts val="0"/>
+              </a:spcAft>
+            </a:pPr>
+          </a:p>
+          <a:p>
+            <a:pPr algn="l">
+              <a:lnSpc>
+                <a:spcPct val="102000"/>
+              </a:lnSpc>
+              <a:spcAft>
+                <a:spcPts val="0"/>
+              </a:spcAft>
+            </a:pPr>
+            <a:r>
+              <a:rPr sz="900" b="0">
+                <a:solidFill>
+                  <a:srgbClr val="1A1A1A"/>
+                </a:solidFill>
+                <a:latin typeface="Consolas"/>
+              </a:rPr>
+              <a:t>    for (int direcao = 0; direcao &lt; 4; direcao++) {</a:t>
+            </a:r>
+          </a:p>
+          <a:p>
+            <a:pPr algn="l">
+              <a:lnSpc>
+                <a:spcPct val="102000"/>
+              </a:lnSpc>
+              <a:spcAft>
+                <a:spcPts val="0"/>
+              </a:spcAft>
+            </a:pPr>
+            <a:r>
+              <a:rPr sz="900" b="0">
+                <a:solidFill>
+                  <a:srgbClr val="5A6472"/>
+                </a:solidFill>
+                <a:latin typeface="Consolas"/>
+              </a:rPr>
+              <a:t>      // vizinho dentro do mapa, piso e nao marcado</a:t>
+            </a:r>
+          </a:p>
+          <a:p>
+            <a:pPr algn="l">
+              <a:lnSpc>
+                <a:spcPct val="102000"/>
+              </a:lnSpc>
+              <a:spcAft>
+                <a:spcPts val="0"/>
+              </a:spcAft>
+            </a:pPr>
+            <a:r>
+              <a:rPr sz="900" b="1">
+                <a:solidFill>
+                  <a:srgbClr val="004AF7"/>
+                </a:solidFill>
+                <a:latin typeface="Consolas"/>
+              </a:rPr>
+              <a:t>      marcado[vizLinha][vizColuna] = true;</a:t>
+            </a:r>
+          </a:p>
+          <a:p>
+            <a:pPr algn="l">
+              <a:lnSpc>
+                <a:spcPct val="102000"/>
+              </a:lnSpc>
+              <a:spcAft>
+                <a:spcPts val="0"/>
+              </a:spcAft>
+            </a:pPr>
+            <a:r>
+              <a:rPr sz="900" b="1">
+                <a:solidFill>
+                  <a:srgbClr val="004AF7"/>
+                </a:solidFill>
+                <a:latin typeface="Consolas"/>
+              </a:rPr>
+              <a:t>      fila.enqueue(vizLinha * colunas + vizColuna);</a:t>
+            </a:r>
+          </a:p>
+          <a:p>
+            <a:pPr algn="l">
+              <a:lnSpc>
+                <a:spcPct val="102000"/>
+              </a:lnSpc>
+              <a:spcAft>
+                <a:spcPts val="0"/>
+              </a:spcAft>
+            </a:pPr>
+            <a:r>
+              <a:rPr sz="900" b="0">
+                <a:solidFill>
+                  <a:srgbClr val="1A1A1A"/>
+                </a:solidFill>
+                <a:latin typeface="Consolas"/>
+              </a:rPr>
+              <a:t>    }</a:t>
+            </a:r>
+          </a:p>
+          <a:p>
+            <a:pPr algn="l">
+              <a:lnSpc>
+                <a:spcPct val="102000"/>
+              </a:lnSpc>
+              <a:spcAft>
+                <a:spcPts val="0"/>
+              </a:spcAft>
+            </a:pPr>
+            <a:r>
+              <a:rPr sz="900" b="0">
+                <a:solidFill>
+                  <a:srgbClr val="1A1A1A"/>
+                </a:solidFill>
+                <a:latin typeface="Consolas"/>
+              </a:rPr>
+              <a:t>  }</a:t>
+            </a:r>
+          </a:p>
+          <a:p>
+            <a:pPr algn="l">
+              <a:lnSpc>
+                <a:spcPct val="102000"/>
+              </a:lnSpc>
+              <a:spcAft>
+                <a:spcPts val="0"/>
+              </a:spcAft>
+            </a:pPr>
+            <a:r>
+              <a:rPr sz="900" b="0">
+                <a:solidFill>
+                  <a:srgbClr val="1A1A1A"/>
+                </a:solidFill>
+                <a:latin typeface="Consolas"/>
+              </a:rPr>
+              <a:t>}</a:t>
+            </a:r>
+          </a:p>
+        </p:txBody>
+      </p:sp>
+    </p:spTree>
+  </p:cSld>
+  <p:clrMapOvr>
+    <a:masterClrMapping/>
+  </p:clrMapOvr>
+</p:sld>
+</file>
+
 <file path=ppt/theme/theme1.xml><?xml version="1.0" encoding="utf-8"?>
 <a:theme xmlns:a="http://schemas.openxmlformats.org/drawingml/2006/main" xmlns:r="http://schemas.openxmlformats.org/officeDocument/2006/relationships">
   <a:themeElements>

</xml_diff>

<commit_message>
feat: adiciona comentario sobre lista de adjacencia
</commit_message>
<xml_diff>
--- a/T1/apresentacao/apresentacao.pptx
+++ b/T1/apresentacao/apresentacao.pptx
@@ -1365,7 +1365,7 @@
           <a:lstStyle/>
           <a:p>
             <a:r>
-              <a:t>Slide 3 (~1 min). Escolhemos a representacao implicita: nao montamos lista de adjacencia nenhuma, a matriz do mapa ja e o grafo. Os vizinhos saem desses dois vetores de deslocamento — cima, baixo, esquerda e direita. A aresta so existe se a posicao estiver dentro da matriz e for piso. O motivo e o tamanho: com um milhao de vertices, guardar as arestas explicitamente custaria memoria a toa, ja que cada vertice tem no maximo quatro vizinhos.</a:t>
+              <a:t>Slide 3 (~1 min). Escolhemos a representacao implicita: nao montamos lista de adjacencia nenhuma, a matriz do mapa ja e o grafo. Os vizinhos saem desses dois vetores de deslocamento — cima, baixo, esquerda e direita. A aresta so existe se a posicao estiver dentro da matriz e for piso. O motivo e o tamanho: com um milhao de vertices, guardar as arestas explicitamente custaria memoria a toa, ja que cada vertice tem no maximo quatro vizinhos. Vale dizer que lista de adjacencia tambem funcionaria: um Bag por posicao, com o vertice numerado como linha vezes colunas mais coluna, e a BFS seria identica. So que, com um milhao de vertices, isso significa uns quatro milhoes de entradas de adjacencia e mais de cem megabytes de nos em Java, para responder exatamente o que a matriz ja responde com dois vetores de deslocamento. Como o grafo e uma grade, o grau e no maximo quatro e o vizinho sai de uma soma: nao ha ganho em materializar as arestas.</a:t>
             </a:r>
           </a:p>
         </p:txBody>
@@ -12419,6 +12419,141 @@
           </a:p>
         </p:txBody>
       </p:sp>
+      <p:sp>
+        <p:nvSpPr>
+          <p:cNvPr id="5" name="TextBox 4"/>
+          <p:cNvSpPr txBox="1"/>
+          <p:nvPr/>
+        </p:nvSpPr>
+        <p:spPr>
+          <a:xfrm>
+            <a:off x="731520" y="4160000"/>
+            <a:ext cx="7200000" cy="620000"/>
+          </a:xfrm>
+          <a:prstGeom prst="rect">
+            <a:avLst/>
+          </a:prstGeom>
+          <a:noFill/>
+        </p:spPr>
+        <p:txBody>
+          <a:bodyPr wrap="square" lIns="0" tIns="0" anchor="t">
+            <a:spAutoFit/>
+          </a:bodyPr>
+          <a:lstStyle/>
+          <a:p>
+            <a:pPr algn="l">
+              <a:lnSpc>
+                <a:spcPct val="105000"/>
+              </a:lnSpc>
+              <a:spcAft>
+                <a:spcPts val="200"/>
+              </a:spcAft>
+            </a:pPr>
+            <a:r>
+              <a:rPr sz="1050" b="1">
+                <a:solidFill>
+                  <a:srgbClr val="132190"/>
+                </a:solidFill>
+                <a:latin typeface="Arial"/>
+              </a:rPr>
+              <a:t>E se fosse lista de adjacência?</a:t>
+            </a:r>
+          </a:p>
+          <a:p>
+            <a:pPr algn="l">
+              <a:lnSpc>
+                <a:spcPct val="105000"/>
+              </a:lnSpc>
+              <a:spcAft>
+                <a:spcPts val="0"/>
+              </a:spcAft>
+            </a:pPr>
+            <a:r>
+              <a:rPr sz="1000" b="0">
+                <a:solidFill>
+                  <a:srgbClr val="5A6472"/>
+                </a:solidFill>
+                <a:latin typeface="Arial"/>
+              </a:rPr>
+              <a:t>Funcionaria igual: um </a:t>
+            </a:r>
+            <a:r>
+              <a:rPr sz="1000" b="0">
+                <a:solidFill>
+                  <a:srgbClr val="5A6472"/>
+                </a:solidFill>
+                <a:latin typeface="Consolas"/>
+              </a:rPr>
+              <a:t>Bag&lt;Integer&gt;</a:t>
+            </a:r>
+            <a:r>
+              <a:rPr sz="1000" b="0">
+                <a:solidFill>
+                  <a:srgbClr val="5A6472"/>
+                </a:solidFill>
+                <a:latin typeface="Arial"/>
+              </a:rPr>
+              <a:t> por posição, vértice </a:t>
+            </a:r>
+            <a:r>
+              <a:rPr sz="1000" b="0">
+                <a:solidFill>
+                  <a:srgbClr val="5A6472"/>
+                </a:solidFill>
+                <a:latin typeface="Consolas"/>
+              </a:rPr>
+              <a:t>id = linha * colunas + coluna</a:t>
+            </a:r>
+            <a:r>
+              <a:rPr sz="1000" b="0">
+                <a:solidFill>
+                  <a:srgbClr val="5A6472"/>
+                </a:solidFill>
+                <a:latin typeface="Arial"/>
+              </a:rPr>
+              <a:t>,</a:t>
+            </a:r>
+          </a:p>
+          <a:p>
+            <a:pPr algn="l">
+              <a:lnSpc>
+                <a:spcPct val="105000"/>
+              </a:lnSpc>
+              <a:spcAft>
+                <a:spcPts val="0"/>
+              </a:spcAft>
+            </a:pPr>
+            <a:r>
+              <a:rPr sz="1000" b="0">
+                <a:solidFill>
+                  <a:srgbClr val="5A6472"/>
+                </a:solidFill>
+                <a:latin typeface="Arial"/>
+              </a:rPr>
+              <a:t>cada piso ligado aos vizinhos piso — mesma BFS, mesma O(H · W).</a:t>
+            </a:r>
+          </a:p>
+          <a:p>
+            <a:pPr algn="l">
+              <a:lnSpc>
+                <a:spcPct val="105000"/>
+              </a:lnSpc>
+              <a:spcAft>
+                <a:spcPts val="0"/>
+              </a:spcAft>
+            </a:pPr>
+            <a:r>
+              <a:rPr sz="1000" b="0">
+                <a:solidFill>
+                  <a:srgbClr val="5A6472"/>
+                </a:solidFill>
+                <a:latin typeface="Arial"/>
+              </a:rPr>
+              <a:t>Mas seriam ~4 milhões de entradas guardadas para responder o que a matriz já responde.</a:t>
+            </a:r>
+          </a:p>
+        </p:txBody>
+      </p:sp>
     </p:spTree>
   </p:cSld>
   <p:clrMapOvr>

</xml_diff>